<commit_message>
fixed typos and added remainig cleanups
</commit_message>
<xml_diff>
--- a/Swish Solar Take home assessment, Interview stage.pptx
+++ b/Swish Solar Take home assessment, Interview stage.pptx
@@ -4242,13 +4242,13 @@
           <a:p>
             <a:r>
               <a:rPr lang="en-US" dirty="0"/>
-              <a:t>First Step was modelling and system Design.</a:t>
+              <a:t>First step was modelling and system design.</a:t>
             </a:r>
           </a:p>
           <a:p>
             <a:r>
               <a:rPr lang="en-US" dirty="0"/>
-              <a:t>Spent about 1 to 1:15 Hours deriving requirements and designs </a:t>
+              <a:t>Spent about 1 to 1:15 hours deriving requirements and designs </a:t>
             </a:r>
           </a:p>
         </p:txBody>
@@ -4382,7 +4382,7 @@
           <a:p>
             <a:r>
               <a:rPr lang="en-US" dirty="0"/>
-              <a:t>Crews cleaning time and cost of cleaning are not static and derived for each crew based on their rate and speed</a:t>
+              <a:t>Crews' cleaning time and cost of cleaning are not static and derived for each crew based on their rate and speed</a:t>
             </a:r>
           </a:p>
           <a:p>
@@ -4396,23 +4396,23 @@
             </a:r>
             <a:r>
               <a:rPr lang="en-US" dirty="0"/>
-              <a:t>-jobs and store the data inside of the database. Edge cases: A) Updates have to invalidate the report and recompute B) failed jobs means no report in the morning -&gt; send compute request</a:t>
+              <a:t>-jobs and store the data inside of the database. Edge cases: A) Updates have to invalidate the report and recompute B) failed jobs mean no report in the morning -&gt; send compute request</a:t>
             </a:r>
           </a:p>
           <a:p>
             <a:r>
               <a:rPr lang="en-US" dirty="0"/>
-              <a:t>Simple Background workers with no broker. Uses the DB. Overhead Pooling is bad but at this rate its not our main concern</a:t>
+              <a:t>Simple background workers with no broker. Uses the DB. Overhead polling is bad but at this rate it's not our main concern</a:t>
             </a:r>
           </a:p>
           <a:p>
             <a:r>
               <a:rPr lang="en-US" dirty="0"/>
-              <a:t>Frontend Is one giant Dashboard with design based on swishsolar.com. See Entities and Make simple </a:t>
+              <a:t>Frontend is one giant dashboard with design based on swishsolar.com. See entities and make simple </a:t>
             </a:r>
             <a:r>
               <a:rPr lang="en-US" dirty="0" err="1"/>
-              <a:t>descions</a:t>
+              <a:t>decisions</a:t>
             </a:r>
             <a:endParaRPr lang="en-US" dirty="0"/>
           </a:p>
@@ -4502,7 +4502,7 @@
           <a:p>
             <a:r>
               <a:rPr lang="en-US" dirty="0"/>
-              <a:t>Redis Caching -&gt; Compute time is the bottleneck, not the Disk VS memory round trip</a:t>
+              <a:t>Redis caching -&gt; Compute time is the bottleneck, not the disk VS memory round trip</a:t>
             </a:r>
           </a:p>
           <a:p>
@@ -4520,7 +4520,7 @@
           <a:p>
             <a:r>
               <a:rPr lang="en-US" dirty="0"/>
-              <a:t>No Automated day entry creation or simulated signal from 3</a:t>
+              <a:t>No automated day entry creation or simulated signal from 3</a:t>
             </a:r>
             <a:r>
               <a:rPr lang="en-US" baseline="30000" dirty="0"/>
@@ -4536,7 +4536,7 @@
             </a:r>
             <a:r>
               <a:rPr lang="en-US" dirty="0"/>
-              <a:t>. Flexible Structure can be expanded for this, but I assumed this to be out of scope</a:t>
+              <a:t>. Flexible structure can be expanded for this, but I assumed this to be out of scope</a:t>
             </a:r>
           </a:p>
         </p:txBody>
@@ -4688,7 +4688,7 @@
           <a:p>
             <a:r>
               <a:rPr lang="en-US" dirty="0"/>
-              <a:t>2: What  I am Unsure</a:t>
+              <a:t>2: What I am Unsure</a:t>
             </a:r>
           </a:p>
         </p:txBody>
@@ -4716,13 +4716,13 @@
           <a:p>
             <a:r>
               <a:rPr lang="en-US" dirty="0"/>
-              <a:t>Lack of understanding of solar energy -&gt; Is how I modeled the energy estimation and the cost calculation correct ? </a:t>
+              <a:t>Lack of understanding of solar energy -&gt; Is how I modeled the energy estimation and the cost calculation correct? </a:t>
             </a:r>
           </a:p>
           <a:p>
             <a:r>
               <a:rPr lang="en-US" dirty="0"/>
-              <a:t>Burst of Users at 8AM -&gt; Which 8AM at which zone ?</a:t>
+              <a:t>Burst of users at 8AM -&gt; Which 8AM at which zone?</a:t>
             </a:r>
           </a:p>
           <a:p>
@@ -4736,13 +4736,13 @@
             </a:r>
             <a:r>
               <a:rPr lang="en-US" dirty="0"/>
-              <a:t> Something we have to take into consideration ? Can one DB/API server all of our users ?</a:t>
+              <a:t> something we have to take into consideration? Can one DB/API serve all of our users?</a:t>
             </a:r>
           </a:p>
           <a:p>
             <a:r>
               <a:rPr lang="en-US" dirty="0"/>
-              <a:t> How long can the system Handle no-dedicated broker for background tasks ?</a:t>
+              <a:t> How long can the system handle no-dedicated broker for background tasks?</a:t>
             </a:r>
           </a:p>
         </p:txBody>
@@ -4828,19 +4828,19 @@
           <a:p>
             <a:r>
               <a:rPr lang="en-US" dirty="0"/>
-              <a:t>Auth system: Every user can see everything/edit everything. Any Authenticated user has total access</a:t>
+              <a:t>Auth system: Every user can see everything/edit everything. Any authenticated user has total access</a:t>
             </a:r>
           </a:p>
           <a:p>
             <a:r>
               <a:rPr lang="en-US" dirty="0"/>
-              <a:t>Pre-compute system is a bit unreliable. A system wide failure will spike usage at morning and bring down service. No retry or observability baked in</a:t>
+              <a:t>Pre-compute system is a bit unreliable. A system-wide failure will spike usage in the morning and bring down service. No retry or observability baked in</a:t>
             </a:r>
           </a:p>
           <a:p>
             <a:r>
               <a:rPr lang="en-US" dirty="0"/>
-              <a:t>Database has no backup; meaning a outage/data loss is lethal for it</a:t>
+              <a:t>Database has no backup; meaning an outage/data loss is lethal for it</a:t>
             </a:r>
           </a:p>
           <a:p>
@@ -4959,11 +4959,11 @@
           <a:p>
             <a:r>
               <a:rPr lang="en-US" dirty="0" err="1"/>
-              <a:t>ServerSide</a:t>
+              <a:t>Server-Sent Events (SSE)</a:t>
             </a:r>
             <a:r>
               <a:rPr lang="en-US" dirty="0"/>
-              <a:t>-events instead of needing to refresh for updates to arrive for analytics</a:t>
+              <a:t> instead of needing to refresh for updates to arrive for analytics</a:t>
             </a:r>
           </a:p>
         </p:txBody>
@@ -5049,13 +5049,13 @@
           <a:p>
             <a:r>
               <a:rPr lang="en-US" dirty="0"/>
-              <a:t>How high-level/low-level should decision log Be ?</a:t>
+              <a:t>How high-level/low-level should decision log be?</a:t>
             </a:r>
           </a:p>
           <a:p>
             <a:r>
               <a:rPr lang="en-US" dirty="0"/>
-              <a:t>Any Dealbreaker features needed ?</a:t>
+              <a:t>Any dealbreaker features needed?</a:t>
             </a:r>
           </a:p>
           <a:p>

</xml_diff>